<commit_message>
Sacar la ruta local del PPTX y poner texto alternativo en las imagenes
Las imagenes se insertaban con su ruta absoluta, que quedaba guardada como
texto alternativo dentro del archivo. Ahora cada imagen tiene una
descripcion propia.
</commit_message>
<xml_diff>
--- a/presentacion/Jenga_de_Cultura_General.pptx
+++ b/presentacion/Jenga_de_Cultura_General.pptx
@@ -2230,7 +2230,7 @@
       </p:sp>
       <p:pic>
         <p:nvPicPr>
-          <p:cNvPr id="11" name="Image 0" descr="C:\Users\joaqu\Juego-Nietardo\presentacion\img\bloques.png">    </p:cNvPr>
+          <p:cNvPr id="11" name="Image 0" descr="Tres bloques del juego, uno de cada nivel, con una, dos y tres ranuras">    </p:cNvPr>
           <p:cNvPicPr>
             <a:picLocks noChangeAspect="1"/>
           </p:cNvPicPr>
@@ -2357,7 +2357,7 @@
       </p:sp>
       <p:pic>
         <p:nvPicPr>
-          <p:cNvPr id="4" name="Image 0" descr="C:\Users\joaqu\Juego-Nietardo\presentacion\img\piezas.png">    </p:cNvPr>
+          <p:cNvPr id="4" name="Image 0" descr="Base de la torre y porta-cartas impresos en 3D">    </p:cNvPr>
           <p:cNvPicPr>
             <a:picLocks noChangeAspect="1"/>
           </p:cNvPicPr>
@@ -4042,7 +4042,7 @@
       </p:sp>
       <p:pic>
         <p:nvPicPr>
-          <p:cNvPr id="7" name="Image 0" descr="C:\Users\joaqu\Juego-Nietardo\presentacion\img\bloques.png">    </p:cNvPr>
+          <p:cNvPr id="7" name="Image 0" descr="Tres bloques del juego, uno de cada nivel, con una, dos y tres ranuras">    </p:cNvPr>
           <p:cNvPicPr>
             <a:picLocks noChangeAspect="1"/>
           </p:cNvPicPr>
@@ -5217,7 +5217,7 @@
       </p:sp>
       <p:pic>
         <p:nvPicPr>
-          <p:cNvPr id="4" name="Image 0" descr="C:\Users\joaqu\Juego-Nietardo\presentacion\img\bloques.png">    </p:cNvPr>
+          <p:cNvPr id="4" name="Image 0" descr="Tres bloques del juego, uno de cada nivel, con una, dos y tres ranuras">    </p:cNvPr>
           <p:cNvPicPr>
             <a:picLocks noChangeAspect="1"/>
           </p:cNvPicPr>
@@ -9384,7 +9384,7 @@
       </p:sp>
       <p:pic>
         <p:nvPicPr>
-          <p:cNvPr id="4" name="Image 0" descr="C:\Users\joaqu\Juego-Nietardo\presentacion\img\cartas.png">    </p:cNvPr>
+          <p:cNvPr id="4" name="Image 0" descr="Tres cartas de preguntas, una de cada nivel">    </p:cNvPr>
           <p:cNvPicPr>
             <a:picLocks noChangeAspect="1"/>
           </p:cNvPicPr>

</xml_diff>

<commit_message>
Quitar el bono de cultura general
Se elimina la regla de +3 puntos por acertar una carta de cada una de
las cinco materias. Queda el sistema de puntaje en dos reglas: acertar
suma 1, 2 o 3 segun el nivel, y errar resta 1 sin bajar de cero.

Ajustes que arrastra:
- Reglas: la seccion "Los puntos" queda con los tres niveles y un solo
  panel, el de restar un punto, a todo el ancho.
- Hoja de puntaje: se va el bloque de casilleros por materia y la tabla
  vuelve de 16 a 20 turnos.
- Sistema de puntajes: "las dos reglas" en lugar de tres, y el ejemplo
  se rehizo con los totales recalculados.
- Presentacion: la diapositiva del puntaje pasa de tres tarjetas a dos.
- Informe (pdf y docx): sale la regla y tambien la justificacion de por
  que se habia agregado.
- README.

De paso se corrige la redaccion de "en vez de al mas dificil", que
estaba mal construida, en las reglas y en el sistema de puntajes.
</commit_message>
<xml_diff>
--- a/presentacion/Jenga_de_Cultura_General.pptx
+++ b/presentacion/Jenga_de_Cultura_General.pptx
@@ -861,7 +861,7 @@
           <a:p>
             <a:r>
               <a:rPr lang="en-US" dirty="0"/>
-              <a:t>Sin el −1, siempre convenía ir al bloque más difícil: arriesgar era gratis. Sin el bono, cada uno se quedaba cazando su propia materia. Las dos reglas salieron de probar el juego.</a:t>
+              <a:t>Sin el −1, siempre convenía ir al bloque más difícil que se pudiera alcanzar: arriesgar era gratis y los bloques de nivel 1 no los elegía nadie. La regla salió de probar el juego.</a:t>
             </a:r>
             <a:endParaRPr lang="en-US" dirty="0"/>
           </a:p>
@@ -4624,7 +4624,7 @@
                 <a:ea typeface="Cambria" pitchFamily="34" charset="-122"/>
                 <a:cs typeface="Cambria" pitchFamily="34" charset="-120"/>
               </a:rPr>
-              <a:t>Tres reglas que obligan a elegir</a:t>
+              <a:t>Cuánto suma y cuánto cuesta</a:t>
             </a:r>
             <a:endParaRPr lang="en-US" sz="4000" dirty="0"/>
           </a:p>
@@ -4639,7 +4639,7 @@
         <p:spPr>
           <a:xfrm>
             <a:off x="713232" y="2148840"/>
-            <a:ext cx="3383280" cy="2331720"/>
+            <a:ext cx="5257800" cy="2331720"/>
           </a:xfrm>
           <a:prstGeom prst="roundRect">
             <a:avLst>
@@ -4665,24 +4665,24 @@
         </p:nvSpPr>
         <p:spPr>
           <a:xfrm>
-            <a:off x="1005840" y="2395728"/>
-            <a:ext cx="2834640" cy="777240"/>
-          </a:xfrm>
-          <a:prstGeom prst="rect">
-            <a:avLst/>
-          </a:prstGeom>
-          <a:noFill/>
-          <a:ln/>
-        </p:spPr>
-        <p:txBody>
-          <a:bodyPr wrap="square" lIns="0" tIns="0" rIns="0" bIns="0" rtlCol="0" anchor="ctr"/>
-          <a:lstStyle/>
-          <a:p>
-            <a:pPr indent="0" marL="0">
-              <a:buNone/>
-            </a:pPr>
-            <a:r>
-              <a:rPr lang="en-US" sz="3000" b="1" dirty="0">
+            <a:off x="1078992" y="2395728"/>
+            <a:ext cx="4572000" cy="777240"/>
+          </a:xfrm>
+          <a:prstGeom prst="rect">
+            <a:avLst/>
+          </a:prstGeom>
+          <a:noFill/>
+          <a:ln/>
+        </p:spPr>
+        <p:txBody>
+          <a:bodyPr wrap="square" lIns="0" tIns="0" rIns="0" bIns="0" rtlCol="0" anchor="ctr"/>
+          <a:lstStyle/>
+          <a:p>
+            <a:pPr indent="0" marL="0">
+              <a:buNone/>
+            </a:pPr>
+            <a:r>
+              <a:rPr lang="en-US" sz="3400" b="1" dirty="0">
                 <a:solidFill>
                   <a:srgbClr val="FF8A6B"/>
                 </a:solidFill>
@@ -4692,7 +4692,7 @@
               </a:rPr>
               <a:t>1 · 2 · 3</a:t>
             </a:r>
-            <a:endParaRPr lang="en-US" sz="3000" dirty="0"/>
+            <a:endParaRPr lang="en-US" sz="3400" dirty="0"/>
           </a:p>
         </p:txBody>
       </p:sp>
@@ -4704,24 +4704,24 @@
         </p:nvSpPr>
         <p:spPr>
           <a:xfrm>
-            <a:off x="1005840" y="3291840"/>
-            <a:ext cx="2834640" cy="365760"/>
-          </a:xfrm>
-          <a:prstGeom prst="rect">
-            <a:avLst/>
-          </a:prstGeom>
-          <a:noFill/>
-          <a:ln/>
-        </p:spPr>
-        <p:txBody>
-          <a:bodyPr wrap="square" lIns="0" tIns="0" rIns="0" bIns="0" rtlCol="0" anchor="ctr"/>
-          <a:lstStyle/>
-          <a:p>
-            <a:pPr indent="0" marL="0">
-              <a:buNone/>
-            </a:pPr>
-            <a:r>
-              <a:rPr lang="en-US" sz="1600" b="1" dirty="0">
+            <a:off x="1078992" y="3291840"/>
+            <a:ext cx="4572000" cy="365760"/>
+          </a:xfrm>
+          <a:prstGeom prst="rect">
+            <a:avLst/>
+          </a:prstGeom>
+          <a:noFill/>
+          <a:ln/>
+        </p:spPr>
+        <p:txBody>
+          <a:bodyPr wrap="square" lIns="0" tIns="0" rIns="0" bIns="0" rtlCol="0" anchor="ctr"/>
+          <a:lstStyle/>
+          <a:p>
+            <a:pPr indent="0" marL="0">
+              <a:buNone/>
+            </a:pPr>
+            <a:r>
+              <a:rPr lang="en-US" sz="1700" b="1" dirty="0">
                 <a:solidFill>
                   <a:srgbClr val="FFFFFF"/>
                 </a:solidFill>
@@ -4731,7 +4731,7 @@
               </a:rPr>
               <a:t>Según el nivel</a:t>
             </a:r>
-            <a:endParaRPr lang="en-US" sz="1600" dirty="0"/>
+            <a:endParaRPr lang="en-US" sz="1700" dirty="0"/>
           </a:p>
         </p:txBody>
       </p:sp>
@@ -4743,8 +4743,8 @@
         </p:nvSpPr>
         <p:spPr>
           <a:xfrm>
-            <a:off x="1005840" y="3703320"/>
-            <a:ext cx="2834640" cy="731520"/>
+            <a:off x="1078992" y="3703320"/>
+            <a:ext cx="4480560" cy="731520"/>
           </a:xfrm>
           <a:prstGeom prst="rect">
             <a:avLst/>
@@ -4758,12 +4758,12 @@
           <a:p>
             <a:pPr indent="0" marL="0">
               <a:lnSpc>
-                <a:spcPts val="1700"/>
+                <a:spcPts val="1800"/>
               </a:lnSpc>
               <a:buNone/>
             </a:pPr>
             <a:r>
-              <a:rPr lang="en-US" sz="1300" dirty="0">
+              <a:rPr lang="en-US" sz="1350" dirty="0">
                 <a:solidFill>
                   <a:srgbClr val="8E96A8"/>
                 </a:solidFill>
@@ -4771,9 +4771,9 @@
                 <a:ea typeface="Calibri" pitchFamily="34" charset="-122"/>
                 <a:cs typeface="Calibri" pitchFamily="34" charset="-120"/>
               </a:rPr>
-              <a:t>Acertás y sumás los puntos que valga el bloque.</a:t>
-            </a:r>
-            <a:endParaRPr lang="en-US" sz="1300" dirty="0"/>
+              <a:t>Acertás y sumás los puntos que valga el bloque que sacaste.</a:t>
+            </a:r>
+            <a:endParaRPr lang="en-US" sz="1350" dirty="0"/>
           </a:p>
         </p:txBody>
       </p:sp>
@@ -4785,8 +4785,8 @@
         </p:nvSpPr>
         <p:spPr>
           <a:xfrm>
-            <a:off x="4325112" y="2148840"/>
-            <a:ext cx="3383280" cy="2331720"/>
+            <a:off x="6199632" y="2148840"/>
+            <a:ext cx="5257800" cy="2331720"/>
           </a:xfrm>
           <a:prstGeom prst="roundRect">
             <a:avLst>
@@ -4812,24 +4812,24 @@
         </p:nvSpPr>
         <p:spPr>
           <a:xfrm>
-            <a:off x="4617720" y="2395728"/>
-            <a:ext cx="2834640" cy="777240"/>
-          </a:xfrm>
-          <a:prstGeom prst="rect">
-            <a:avLst/>
-          </a:prstGeom>
-          <a:noFill/>
-          <a:ln/>
-        </p:spPr>
-        <p:txBody>
-          <a:bodyPr wrap="square" lIns="0" tIns="0" rIns="0" bIns="0" rtlCol="0" anchor="ctr"/>
-          <a:lstStyle/>
-          <a:p>
-            <a:pPr indent="0" marL="0">
-              <a:buNone/>
-            </a:pPr>
-            <a:r>
-              <a:rPr lang="en-US" sz="4400" b="1" dirty="0">
+            <a:off x="6565392" y="2395728"/>
+            <a:ext cx="4572000" cy="777240"/>
+          </a:xfrm>
+          <a:prstGeom prst="rect">
+            <a:avLst/>
+          </a:prstGeom>
+          <a:noFill/>
+          <a:ln/>
+        </p:spPr>
+        <p:txBody>
+          <a:bodyPr wrap="square" lIns="0" tIns="0" rIns="0" bIns="0" rtlCol="0" anchor="ctr"/>
+          <a:lstStyle/>
+          <a:p>
+            <a:pPr indent="0" marL="0">
+              <a:buNone/>
+            </a:pPr>
+            <a:r>
+              <a:rPr lang="en-US" sz="4600" b="1" dirty="0">
                 <a:solidFill>
                   <a:srgbClr val="FF8A6B"/>
                 </a:solidFill>
@@ -4839,7 +4839,7 @@
               </a:rPr>
               <a:t>−1</a:t>
             </a:r>
-            <a:endParaRPr lang="en-US" sz="4400" dirty="0"/>
+            <a:endParaRPr lang="en-US" sz="4600" dirty="0"/>
           </a:p>
         </p:txBody>
       </p:sp>
@@ -4851,24 +4851,24 @@
         </p:nvSpPr>
         <p:spPr>
           <a:xfrm>
-            <a:off x="4617720" y="3291840"/>
-            <a:ext cx="2834640" cy="365760"/>
-          </a:xfrm>
-          <a:prstGeom prst="rect">
-            <a:avLst/>
-          </a:prstGeom>
-          <a:noFill/>
-          <a:ln/>
-        </p:spPr>
-        <p:txBody>
-          <a:bodyPr wrap="square" lIns="0" tIns="0" rIns="0" bIns="0" rtlCol="0" anchor="ctr"/>
-          <a:lstStyle/>
-          <a:p>
-            <a:pPr indent="0" marL="0">
-              <a:buNone/>
-            </a:pPr>
-            <a:r>
-              <a:rPr lang="en-US" sz="1600" b="1" dirty="0">
+            <a:off x="6565392" y="3291840"/>
+            <a:ext cx="4572000" cy="365760"/>
+          </a:xfrm>
+          <a:prstGeom prst="rect">
+            <a:avLst/>
+          </a:prstGeom>
+          <a:noFill/>
+          <a:ln/>
+        </p:spPr>
+        <p:txBody>
+          <a:bodyPr wrap="square" lIns="0" tIns="0" rIns="0" bIns="0" rtlCol="0" anchor="ctr"/>
+          <a:lstStyle/>
+          <a:p>
+            <a:pPr indent="0" marL="0">
+              <a:buNone/>
+            </a:pPr>
+            <a:r>
+              <a:rPr lang="en-US" sz="1700" b="1" dirty="0">
                 <a:solidFill>
                   <a:srgbClr val="FFFFFF"/>
                 </a:solidFill>
@@ -4878,7 +4878,7 @@
               </a:rPr>
               <a:t>Si errás</a:t>
             </a:r>
-            <a:endParaRPr lang="en-US" sz="1600" dirty="0"/>
+            <a:endParaRPr lang="en-US" sz="1700" dirty="0"/>
           </a:p>
         </p:txBody>
       </p:sp>
@@ -4890,8 +4890,8 @@
         </p:nvSpPr>
         <p:spPr>
           <a:xfrm>
-            <a:off x="4617720" y="3703320"/>
-            <a:ext cx="2834640" cy="731520"/>
+            <a:off x="6565392" y="3703320"/>
+            <a:ext cx="4480560" cy="731520"/>
           </a:xfrm>
           <a:prstGeom prst="rect">
             <a:avLst/>
@@ -4905,12 +4905,12 @@
           <a:p>
             <a:pPr indent="0" marL="0">
               <a:lnSpc>
-                <a:spcPts val="1700"/>
+                <a:spcPts val="1800"/>
               </a:lnSpc>
               <a:buNone/>
             </a:pPr>
             <a:r>
-              <a:rPr lang="en-US" sz="1300" dirty="0">
+              <a:rPr lang="en-US" sz="1350" dirty="0">
                 <a:solidFill>
                   <a:srgbClr val="8E96A8"/>
                 </a:solidFill>
@@ -4918,162 +4918,15 @@
                 <a:ea typeface="Calibri" pitchFamily="34" charset="-122"/>
                 <a:cs typeface="Calibri" pitchFamily="34" charset="-120"/>
               </a:rPr>
-              <a:t>Nunca bajás de cero, pero arriesgar de más cuesta.</a:t>
-            </a:r>
-            <a:endParaRPr lang="en-US" sz="1300" dirty="0"/>
-          </a:p>
-        </p:txBody>
-      </p:sp>
-      <p:sp>
-        <p:nvSpPr>
-          <p:cNvPr id="12" name="Shape 10"/>
-          <p:cNvSpPr/>
-          <p:nvPr/>
-        </p:nvSpPr>
-        <p:spPr>
-          <a:xfrm>
-            <a:off x="7936992" y="2148840"/>
-            <a:ext cx="3383280" cy="2331720"/>
-          </a:xfrm>
-          <a:prstGeom prst="roundRect">
-            <a:avLst>
-              <a:gd name="adj" fmla="val 3137"/>
-            </a:avLst>
-          </a:prstGeom>
-          <a:solidFill>
-            <a:srgbClr val="3A2320"/>
-          </a:solidFill>
-          <a:ln w="12700">
-            <a:solidFill>
-              <a:srgbClr val="3A2320"/>
-            </a:solidFill>
-            <a:prstDash val="solid"/>
-          </a:ln>
-        </p:spPr>
-      </p:sp>
-      <p:sp>
-        <p:nvSpPr>
-          <p:cNvPr id="13" name="Text 11"/>
-          <p:cNvSpPr txBox="1"/>
-          <p:nvPr/>
-        </p:nvSpPr>
-        <p:spPr>
-          <a:xfrm>
-            <a:off x="8229600" y="2395728"/>
-            <a:ext cx="2834640" cy="777240"/>
-          </a:xfrm>
-          <a:prstGeom prst="rect">
-            <a:avLst/>
-          </a:prstGeom>
-          <a:noFill/>
-          <a:ln/>
-        </p:spPr>
-        <p:txBody>
-          <a:bodyPr wrap="square" lIns="0" tIns="0" rIns="0" bIns="0" rtlCol="0" anchor="ctr"/>
-          <a:lstStyle/>
-          <a:p>
-            <a:pPr indent="0" marL="0">
-              <a:buNone/>
-            </a:pPr>
-            <a:r>
-              <a:rPr lang="en-US" sz="4400" b="1" dirty="0">
-                <a:solidFill>
-                  <a:srgbClr val="FF8A6B"/>
-                </a:solidFill>
-                <a:latin typeface="Cambria" pitchFamily="34" charset="0"/>
-                <a:ea typeface="Cambria" pitchFamily="34" charset="-122"/>
-                <a:cs typeface="Cambria" pitchFamily="34" charset="-120"/>
-              </a:rPr>
-              <a:t>+3</a:t>
-            </a:r>
-            <a:endParaRPr lang="en-US" sz="4400" dirty="0"/>
-          </a:p>
-        </p:txBody>
-      </p:sp>
-      <p:sp>
-        <p:nvSpPr>
-          <p:cNvPr id="14" name="Text 12"/>
-          <p:cNvSpPr txBox="1"/>
-          <p:nvPr/>
-        </p:nvSpPr>
-        <p:spPr>
-          <a:xfrm>
-            <a:off x="8229600" y="3291840"/>
-            <a:ext cx="2834640" cy="365760"/>
-          </a:xfrm>
-          <a:prstGeom prst="rect">
-            <a:avLst/>
-          </a:prstGeom>
-          <a:noFill/>
-          <a:ln/>
-        </p:spPr>
-        <p:txBody>
-          <a:bodyPr wrap="square" lIns="0" tIns="0" rIns="0" bIns="0" rtlCol="0" anchor="ctr"/>
-          <a:lstStyle/>
-          <a:p>
-            <a:pPr indent="0" marL="0">
-              <a:buNone/>
-            </a:pPr>
-            <a:r>
-              <a:rPr lang="en-US" sz="1600" b="1" dirty="0">
-                <a:solidFill>
-                  <a:srgbClr val="FFFFFF"/>
-                </a:solidFill>
-                <a:latin typeface="Calibri" pitchFamily="34" charset="0"/>
-                <a:ea typeface="Calibri" pitchFamily="34" charset="-122"/>
-                <a:cs typeface="Calibri" pitchFamily="34" charset="-120"/>
-              </a:rPr>
-              <a:t>Bono de cultura general</a:t>
-            </a:r>
-            <a:endParaRPr lang="en-US" sz="1600" dirty="0"/>
-          </a:p>
-        </p:txBody>
-      </p:sp>
-      <p:sp>
-        <p:nvSpPr>
-          <p:cNvPr id="15" name="Text 13"/>
-          <p:cNvSpPr txBox="1"/>
-          <p:nvPr/>
-        </p:nvSpPr>
-        <p:spPr>
-          <a:xfrm>
-            <a:off x="8229600" y="3703320"/>
-            <a:ext cx="2834640" cy="731520"/>
-          </a:xfrm>
-          <a:prstGeom prst="rect">
-            <a:avLst/>
-          </a:prstGeom>
-          <a:noFill/>
-          <a:ln/>
-        </p:spPr>
-        <p:txBody>
-          <a:bodyPr wrap="square" lIns="0" tIns="0" rIns="0" bIns="0" rtlCol="0" anchor="ctr"/>
-          <a:lstStyle/>
-          <a:p>
-            <a:pPr indent="0" marL="0">
-              <a:lnSpc>
-                <a:spcPts val="1700"/>
-              </a:lnSpc>
-              <a:buNone/>
-            </a:pPr>
-            <a:r>
-              <a:rPr lang="en-US" sz="1300" dirty="0">
-                <a:solidFill>
-                  <a:srgbClr val="8E96A8"/>
-                </a:solidFill>
-                <a:latin typeface="Calibri" pitchFamily="34" charset="0"/>
-                <a:ea typeface="Calibri" pitchFamily="34" charset="-122"/>
-                <a:cs typeface="Calibri" pitchFamily="34" charset="-120"/>
-              </a:rPr>
-              <a:t>La primera vez que acertás una carta de cada materia.</a:t>
-            </a:r>
-            <a:endParaRPr lang="en-US" sz="1300" dirty="0"/>
-          </a:p>
-        </p:txBody>
-      </p:sp>
-      <p:sp>
-        <p:nvSpPr>
-          <p:cNvPr id="16" name="Text 14"/>
+              <a:t>Nunca bajás de cero, pero arriesgar de más te cuesta puntos.</a:t>
+            </a:r>
+            <a:endParaRPr lang="en-US" sz="1350" dirty="0"/>
+          </a:p>
+        </p:txBody>
+      </p:sp>
+      <p:sp>
+        <p:nvSpPr>
+          <p:cNvPr id="12" name="Text 10"/>
           <p:cNvSpPr txBox="1"/>
           <p:nvPr/>
         </p:nvSpPr>
@@ -5107,7 +4960,7 @@
                 <a:ea typeface="Calibri" pitchFamily="34" charset="-122"/>
                 <a:cs typeface="Calibri" pitchFamily="34" charset="-120"/>
               </a:rPr>
-              <a:t>El nivel te da los puntos, errar te los quita y el bono te empuja a salir de tu materia favorita. Y arriba de todo, la torre.</a:t>
+              <a:t>El nivel te da los puntos y errar te los quita. Y arriba de todo, la torre.</a:t>
             </a:r>
             <a:endParaRPr lang="en-US" sz="1600" dirty="0"/>
           </a:p>

</xml_diff>